<commit_message>
feat: Update AI JIRA Story Generator Business Deck presentation
</commit_message>
<xml_diff>
--- a/AI-JIRA-Story-Generator-Business-Deck.pptx
+++ b/AI-JIRA-Story-Generator-Business-Deck.pptx
@@ -6899,8 +6899,50 @@
         </p:nvSpPr>
         <p:spPr>
           <a:xfrm>
-            <a:off x="822960" y="1828800"/>
-            <a:ext cx="10515600" cy="1828800"/>
+            <a:off x="822960" y="640080"/>
+            <a:ext cx="10515600" cy="411480"/>
+          </a:xfrm>
+          <a:prstGeom prst="rect">
+            <a:avLst/>
+          </a:prstGeom>
+          <a:noFill/>
+        </p:spPr>
+        <p:txBody>
+          <a:bodyPr wrap="square" anchor="t" lIns="0" rIns="0" tIns="0" bIns="0">
+            <a:spAutoFit/>
+          </a:bodyPr>
+          <a:lstStyle/>
+          <a:p>
+            <a:pPr algn="l">
+              <a:spcBef>
+                <a:spcPts val="0"/>
+              </a:spcBef>
+              <a:spcAft>
+                <a:spcPts val="0"/>
+              </a:spcAft>
+            </a:pPr>
+            <a:r>
+              <a:rPr sz="1300" b="1">
+                <a:solidFill>
+                  <a:srgbClr val="10B981"/>
+                </a:solidFill>
+                <a:latin typeface="Segoe UI"/>
+              </a:rPr>
+              <a:t>CONCLUSION</a:t>
+            </a:r>
+          </a:p>
+        </p:txBody>
+      </p:sp>
+      <p:sp>
+        <p:nvSpPr>
+          <p:cNvPr id="6" name="TextBox 5"/>
+          <p:cNvSpPr txBox="1"/>
+          <p:nvPr/>
+        </p:nvSpPr>
+        <p:spPr>
+          <a:xfrm>
+            <a:off x="822960" y="1051560"/>
+            <a:ext cx="10515600" cy="1737360"/>
           </a:xfrm>
           <a:prstGeom prst="rect">
             <a:avLst/>
@@ -6922,13 +6964,13 @@
               </a:spcAft>
             </a:pPr>
             <a:r>
-              <a:rPr sz="4000" b="1">
+              <a:rPr sz="3400" b="1">
                 <a:solidFill>
                   <a:srgbClr val="FFFFFF"/>
                 </a:solidFill>
                 <a:latin typeface="Segoe UI"/>
               </a:rPr>
-              <a:t>Write the backlog in minutes.</a:t>
+              <a:t>A validated backlog in minutes — not hours.</a:t>
             </a:r>
           </a:p>
           <a:p>
@@ -6941,26 +6983,26 @@
               </a:spcAft>
             </a:pPr>
             <a:r>
-              <a:rPr sz="1800" b="0">
+              <a:rPr sz="1600" b="0">
                 <a:solidFill>
                   <a:srgbClr val="C7CBE8"/>
                 </a:solidFill>
                 <a:latin typeface="Segoe UI"/>
               </a:rPr>
-              <a:t>Give your BAs their time back — and your board the numbers to prove it.</a:t>
-            </a:r>
-          </a:p>
-        </p:txBody>
-      </p:sp>
-      <p:sp>
-        <p:nvSpPr>
-          <p:cNvPr id="6" name="Rectangle 5"/>
+              <a:t>The AI JIRA Story Generator turns unstructured conversations into grounded, quality-scored, compliant work items and files them straight into JIRA.</a:t>
+            </a:r>
+          </a:p>
+        </p:txBody>
+      </p:sp>
+      <p:sp>
+        <p:nvSpPr>
+          <p:cNvPr id="7" name="Rectangle 6"/>
           <p:cNvSpPr/>
           <p:nvPr/>
         </p:nvSpPr>
         <p:spPr>
           <a:xfrm>
-            <a:off x="868680" y="3794760"/>
+            <a:off x="868680" y="3108960"/>
             <a:ext cx="2011680" cy="45720"/>
           </a:xfrm>
           <a:prstGeom prst="rect">
@@ -6998,14 +7040,14 @@
       </p:sp>
       <p:sp>
         <p:nvSpPr>
-          <p:cNvPr id="7" name="TextBox 6"/>
+          <p:cNvPr id="8" name="TextBox 7"/>
           <p:cNvSpPr txBox="1"/>
           <p:nvPr/>
         </p:nvSpPr>
         <p:spPr>
           <a:xfrm>
-            <a:off x="822960" y="4114800"/>
-            <a:ext cx="10515600" cy="1828800"/>
+            <a:off x="822960" y="3429000"/>
+            <a:ext cx="10515600" cy="2743200"/>
           </a:xfrm>
           <a:prstGeom prst="rect">
             <a:avLst/>
@@ -7023,7 +7065,7 @@
                 <a:spcPts val="0"/>
               </a:spcBef>
               <a:spcAft>
-                <a:spcPts val="1200"/>
+                <a:spcPts val="1400"/>
               </a:spcAft>
             </a:pPr>
             <a:r>
@@ -7033,7 +7075,7 @@
                 </a:solidFill>
                 <a:latin typeface="Segoe UI"/>
               </a:rPr>
-              <a:t>→  </a:t>
+              <a:t>✓  </a:t>
             </a:r>
             <a:r>
               <a:rPr sz="1500" b="0">
@@ -7042,7 +7084,7 @@
                 </a:solidFill>
                 <a:latin typeface="Segoe UI"/>
               </a:rPr>
-              <a:t>Pilot on one team's live backlog for 30 days</a:t>
+              <a:t>~80% less BA authoring effort — about 150 hours reclaimed per team each month</a:t>
             </a:r>
           </a:p>
           <a:p>
@@ -7051,7 +7093,7 @@
                 <a:spcPts val="0"/>
               </a:spcBef>
               <a:spcAft>
-                <a:spcPts val="1200"/>
+                <a:spcPts val="1400"/>
               </a:spcAft>
             </a:pPr>
             <a:r>
@@ -7061,7 +7103,7 @@
                 </a:solidFill>
                 <a:latin typeface="Segoe UI"/>
               </a:rPr>
-              <a:t>→  </a:t>
+              <a:t>✓  </a:t>
             </a:r>
             <a:r>
               <a:rPr sz="1500" b="0">
@@ -7070,7 +7112,7 @@
                 </a:solidFill>
                 <a:latin typeface="Segoe UI"/>
               </a:rPr>
-              <a:t>Measure against your real BA hours and billing rates</a:t>
+              <a:t>~$1.0M+ in annual billing savings at 8 delivery teams (illustrative)</a:t>
             </a:r>
           </a:p>
           <a:p>
@@ -7079,7 +7121,7 @@
                 <a:spcPts val="0"/>
               </a:spcBef>
               <a:spcAft>
-                <a:spcPts val="1200"/>
+                <a:spcPts val="1400"/>
               </a:spcAft>
             </a:pPr>
             <a:r>
@@ -7089,7 +7131,7 @@
                 </a:solidFill>
                 <a:latin typeface="Segoe UI"/>
               </a:rPr>
-              <a:t>→  </a:t>
+              <a:t>✓  </a:t>
             </a:r>
             <a:r>
               <a:rPr sz="1500" b="0">
@@ -7098,20 +7140,48 @@
                 </a:solidFill>
                 <a:latin typeface="Segoe UI"/>
               </a:rPr>
-              <a:t>Scale team-by-team as savings compound</a:t>
-            </a:r>
-          </a:p>
-        </p:txBody>
-      </p:sp>
-      <p:sp>
-        <p:nvSpPr>
-          <p:cNvPr id="8" name="TextBox 7"/>
+              <a:t>Grounded, self-verifying and compliance-first — it asks when unsure and gates weak output</a:t>
+            </a:r>
+          </a:p>
+          <a:p>
+            <a:pPr>
+              <a:spcBef>
+                <a:spcPts val="0"/>
+              </a:spcBef>
+              <a:spcAft>
+                <a:spcPts val="1400"/>
+              </a:spcAft>
+            </a:pPr>
+            <a:r>
+              <a:rPr sz="1500" b="1">
+                <a:solidFill>
+                  <a:srgbClr val="10B981"/>
+                </a:solidFill>
+                <a:latin typeface="Segoe UI"/>
+              </a:rPr>
+              <a:t>✓  </a:t>
+            </a:r>
+            <a:r>
+              <a:rPr sz="1500" b="0">
+                <a:solidFill>
+                  <a:srgbClr val="E5E7F4"/>
+                </a:solidFill>
+                <a:latin typeface="Segoe UI"/>
+              </a:rPr>
+              <a:t>End-to-end and human-in-the-loop: notes → validated backlog → live JIRA</a:t>
+            </a:r>
+          </a:p>
+        </p:txBody>
+      </p:sp>
+      <p:sp>
+        <p:nvSpPr>
+          <p:cNvPr id="9" name="TextBox 8"/>
           <p:cNvSpPr txBox="1"/>
           <p:nvPr/>
         </p:nvSpPr>
         <p:spPr>
           <a:xfrm>
-            <a:off x="822960" y="6172200"/>
+            <a:off x="822960" y="6309360"/>
             <a:ext cx="10515600" cy="365760"/>
           </a:xfrm>
           <a:prstGeom prst="rect">

</xml_diff>

<commit_message>
feat: Enhance story generation with source type handling and cancellation support
- Added SourceType enum to differentiate between transcript and document inputs.
- Updated extractor to use source type for tailored extraction prompts.
- Implemented titler agent for generating concise titles based on input type.
- Enhanced main application logic to support cancellation of ongoing generation tasks.
- Introduced cancellation service to manage in-flight tasks and user stop requests.
- Updated frontend components to allow users to select source type and stop generation.
- Improved session management to reflect running state and handle auto-naming of sessions.
</commit_message>
<xml_diff>
--- a/AI-JIRA-Story-Generator-Business-Deck.pptx
+++ b/AI-JIRA-Story-Generator-Business-Deck.pptx
@@ -8,6 +8,7 @@
     <p:sldId id="256" r:id="rId7"/>
     <p:sldId id="257" r:id="rId8"/>
     <p:sldId id="258" r:id="rId9"/>
+    <p:sldId id="268" r:id="rId19"/>
     <p:sldId id="259" r:id="rId10"/>
     <p:sldId id="260" r:id="rId11"/>
     <p:sldId id="261" r:id="rId12"/>
@@ -4350,7 +4351,7 @@
                 </a:solidFill>
                 <a:latin typeface="Segoe UI"/>
               </a:rPr>
-              <a:t>From raw meeting notes to a validated, sprint-ready backlog — in minutes.</a:t>
+              <a:t>From meeting notes, transcripts, and BRDs to a validated, sprint-ready backlog — in minutes.</a:t>
             </a:r>
           </a:p>
         </p:txBody>
@@ -6173,7 +6174,7 @@
                 </a:solidFill>
                 <a:latin typeface="Segoe UI"/>
               </a:rPr>
-              <a:t>9</a:t>
+              <a:t>10</a:t>
             </a:r>
           </a:p>
         </p:txBody>
@@ -6615,7 +6616,7 @@
                 </a:solidFill>
                 <a:latin typeface="Segoe UI"/>
               </a:rPr>
-              <a:t>  —  notes → structured, validated backlog → live JIRA items, in one flow, in minutes</a:t>
+              <a:t>  —  transcripts and BRDs → structured, validated backlog → live JIRA items, in one flow, in minutes</a:t>
             </a:r>
           </a:p>
           <a:p>
@@ -6736,7 +6737,7 @@
                 </a:solidFill>
                 <a:latin typeface="Segoe UI"/>
               </a:rPr>
-              <a:t>10</a:t>
+              <a:t>11</a:t>
             </a:r>
           </a:p>
         </p:txBody>
@@ -6989,7 +6990,7 @@
                 </a:solidFill>
                 <a:latin typeface="Segoe UI"/>
               </a:rPr>
-              <a:t>The AI JIRA Story Generator turns unstructured conversations into grounded, quality-scored, compliant work items and files them straight into JIRA.</a:t>
+              <a:t>The AI JIRA Story Generator turns meeting transcripts and BRDs into grounded, quality-scored, compliant work items and files them straight into JIRA.</a:t>
             </a:r>
           </a:p>
         </p:txBody>
@@ -7168,7 +7169,7 @@
                 </a:solidFill>
                 <a:latin typeface="Segoe UI"/>
               </a:rPr>
-              <a:t>End-to-end and human-in-the-loop: notes → validated backlog → live JIRA</a:t>
+              <a:t>End-to-end and human-in-the-loop: transcripts &amp; BRDs → validated backlog → live JIRA</a:t>
             </a:r>
           </a:p>
         </p:txBody>
@@ -7211,6 +7212,532 @@
                 <a:latin typeface="Segoe UI"/>
               </a:rPr>
               <a:t>AI JIRA Story Generator  ·  Business Case  ·  Illustrative model — replace with your actuals</a:t>
+            </a:r>
+          </a:p>
+        </p:txBody>
+      </p:sp>
+    </p:spTree>
+  </p:cSld>
+  <p:clrMapOvr>
+    <a:masterClrMapping/>
+  </p:clrMapOvr>
+</p:sld>
+</file>
+
+<file path=ppt/slides/slide13.xml><?xml version="1.0" encoding="utf-8"?>
+<p:sld xmlns:a="http://schemas.openxmlformats.org/drawingml/2006/main" xmlns:p="http://schemas.openxmlformats.org/presentationml/2006/main" xmlns:r="http://schemas.openxmlformats.org/officeDocument/2006/relationships">
+  <p:cSld>
+    <p:spTree>
+      <p:nvGrpSpPr>
+        <p:cNvPr id="1" name=""/>
+        <p:cNvGrpSpPr/>
+        <p:nvPr/>
+      </p:nvGrpSpPr>
+      <p:grpSpPr/>
+      <p:sp>
+        <p:nvSpPr>
+          <p:cNvPr id="2" name="Rectangle 1"/>
+          <p:cNvSpPr/>
+          <p:nvPr/>
+        </p:nvSpPr>
+        <p:spPr>
+          <a:xfrm>
+            <a:off x="0" y="0"/>
+            <a:ext cx="12191695" cy="6858000"/>
+          </a:xfrm>
+          <a:prstGeom prst="rect">
+            <a:avLst/>
+          </a:prstGeom>
+          <a:solidFill>
+            <a:srgbClr val="FFFFFF"/>
+          </a:solidFill>
+          <a:ln>
+            <a:noFill/>
+          </a:ln>
+          <a:effectLst/>
+        </p:spPr>
+        <p:style>
+          <a:lnRef idx="1">
+            <a:schemeClr val="accent1"/>
+          </a:lnRef>
+          <a:fillRef idx="3">
+            <a:schemeClr val="accent1"/>
+          </a:fillRef>
+          <a:effectRef idx="2">
+            <a:schemeClr val="accent1"/>
+          </a:effectRef>
+          <a:fontRef idx="minor">
+            <a:schemeClr val="lt1"/>
+          </a:fontRef>
+        </p:style>
+        <p:txBody>
+          <a:bodyPr rtlCol="0" anchor="ctr"/>
+          <a:lstStyle/>
+          <a:p>
+            <a:pPr algn="ctr"/>
+          </a:p>
+        </p:txBody>
+      </p:sp>
+      <p:sp>
+        <p:nvSpPr>
+          <p:cNvPr id="3" name="Rectangle 2"/>
+          <p:cNvSpPr/>
+          <p:nvPr/>
+        </p:nvSpPr>
+        <p:spPr>
+          <a:xfrm>
+            <a:off x="0" y="0"/>
+            <a:ext cx="256032" cy="6858000"/>
+          </a:xfrm>
+          <a:prstGeom prst="rect">
+            <a:avLst/>
+          </a:prstGeom>
+          <a:solidFill>
+            <a:srgbClr val="4F46E5"/>
+          </a:solidFill>
+          <a:ln>
+            <a:noFill/>
+          </a:ln>
+          <a:effectLst/>
+        </p:spPr>
+        <p:style>
+          <a:lnRef idx="1">
+            <a:schemeClr val="accent1"/>
+          </a:lnRef>
+          <a:fillRef idx="3">
+            <a:schemeClr val="accent1"/>
+          </a:fillRef>
+          <a:effectRef idx="2">
+            <a:schemeClr val="accent1"/>
+          </a:effectRef>
+          <a:fontRef idx="minor">
+            <a:schemeClr val="lt1"/>
+          </a:fontRef>
+        </p:style>
+        <p:txBody>
+          <a:bodyPr rtlCol="0" anchor="ctr"/>
+          <a:lstStyle/>
+          <a:p>
+            <a:pPr algn="ctr"/>
+          </a:p>
+        </p:txBody>
+      </p:sp>
+      <p:sp>
+        <p:nvSpPr>
+          <p:cNvPr id="4" name="TextBox 3"/>
+          <p:cNvSpPr txBox="1"/>
+          <p:nvPr/>
+        </p:nvSpPr>
+        <p:spPr>
+          <a:xfrm>
+            <a:off x="685800" y="384048"/>
+            <a:ext cx="10515600" cy="365760"/>
+          </a:xfrm>
+          <a:prstGeom prst="rect">
+            <a:avLst/>
+          </a:prstGeom>
+          <a:noFill/>
+        </p:spPr>
+        <p:txBody>
+          <a:bodyPr wrap="square" anchor="t" lIns="0" rIns="0" tIns="0" bIns="0">
+            <a:spAutoFit/>
+          </a:bodyPr>
+          <a:lstStyle/>
+          <a:p>
+            <a:pPr algn="l">
+              <a:spcBef>
+                <a:spcPts val="0"/>
+              </a:spcBef>
+              <a:spcAft>
+                <a:spcPts val="0"/>
+              </a:spcAft>
+            </a:pPr>
+            <a:r>
+              <a:rPr sz="1200" b="1">
+                <a:solidFill>
+                  <a:srgbClr val="4F46E5"/>
+                </a:solidFill>
+                <a:latin typeface="Segoe UI"/>
+              </a:rPr>
+              <a:t>ANY SOURCE IN</a:t>
+            </a:r>
+          </a:p>
+        </p:txBody>
+      </p:sp>
+      <p:sp>
+        <p:nvSpPr>
+          <p:cNvPr id="5" name="TextBox 4"/>
+          <p:cNvSpPr txBox="1"/>
+          <p:nvPr/>
+        </p:nvSpPr>
+        <p:spPr>
+          <a:xfrm>
+            <a:off x="685800" y="713232"/>
+            <a:ext cx="10789920" cy="914400"/>
+          </a:xfrm>
+          <a:prstGeom prst="rect">
+            <a:avLst/>
+          </a:prstGeom>
+          <a:noFill/>
+        </p:spPr>
+        <p:txBody>
+          <a:bodyPr wrap="square" anchor="t" lIns="0" rIns="0" tIns="0" bIns="0">
+            <a:spAutoFit/>
+          </a:bodyPr>
+          <a:lstStyle/>
+          <a:p>
+            <a:pPr algn="l">
+              <a:spcBef>
+                <a:spcPts val="0"/>
+              </a:spcBef>
+              <a:spcAft>
+                <a:spcPts val="0"/>
+              </a:spcAft>
+            </a:pPr>
+            <a:r>
+              <a:rPr sz="2800" b="1">
+                <a:solidFill>
+                  <a:srgbClr val="1F2937"/>
+                </a:solidFill>
+                <a:latin typeface="Segoe UI"/>
+              </a:rPr>
+              <a:t>One agent for meeting transcripts and BRDs alike</a:t>
+            </a:r>
+          </a:p>
+        </p:txBody>
+      </p:sp>
+      <p:sp>
+        <p:nvSpPr>
+          <p:cNvPr id="6" name="Rectangle 5"/>
+          <p:cNvSpPr/>
+          <p:nvPr/>
+        </p:nvSpPr>
+        <p:spPr>
+          <a:xfrm>
+            <a:off x="685800" y="1481328"/>
+            <a:ext cx="2011680" cy="41148"/>
+          </a:xfrm>
+          <a:prstGeom prst="rect">
+            <a:avLst/>
+          </a:prstGeom>
+          <a:solidFill>
+            <a:srgbClr val="10B981"/>
+          </a:solidFill>
+          <a:ln>
+            <a:noFill/>
+          </a:ln>
+          <a:effectLst/>
+        </p:spPr>
+        <p:style>
+          <a:lnRef idx="1">
+            <a:schemeClr val="accent1"/>
+          </a:lnRef>
+          <a:fillRef idx="3">
+            <a:schemeClr val="accent1"/>
+          </a:fillRef>
+          <a:effectRef idx="2">
+            <a:schemeClr val="accent1"/>
+          </a:effectRef>
+          <a:fontRef idx="minor">
+            <a:schemeClr val="lt1"/>
+          </a:fontRef>
+        </p:style>
+        <p:txBody>
+          <a:bodyPr rtlCol="0" anchor="ctr"/>
+          <a:lstStyle/>
+          <a:p>
+            <a:pPr algn="ctr"/>
+          </a:p>
+        </p:txBody>
+      </p:sp>
+      <p:sp>
+        <p:nvSpPr>
+          <p:cNvPr id="7" name="TextBox 6"/>
+          <p:cNvSpPr txBox="1"/>
+          <p:nvPr/>
+        </p:nvSpPr>
+        <p:spPr>
+          <a:xfrm>
+            <a:off x="685800" y="1920240"/>
+            <a:ext cx="10835640" cy="4023360"/>
+          </a:xfrm>
+          <a:prstGeom prst="rect">
+            <a:avLst/>
+          </a:prstGeom>
+          <a:noFill/>
+        </p:spPr>
+        <p:txBody>
+          <a:bodyPr wrap="square" lIns="0" rIns="0" tIns="0" bIns="0">
+            <a:spAutoFit/>
+          </a:bodyPr>
+          <a:lstStyle/>
+          <a:p>
+            <a:pPr>
+              <a:spcBef>
+                <a:spcPts val="0"/>
+              </a:spcBef>
+              <a:spcAft>
+                <a:spcPts val="1500"/>
+              </a:spcAft>
+            </a:pPr>
+            <a:r>
+              <a:rPr sz="1500" b="1">
+                <a:solidFill>
+                  <a:srgbClr val="4F46E5"/>
+                </a:solidFill>
+                <a:latin typeface="Segoe UI"/>
+              </a:rPr>
+              <a:t>●  </a:t>
+            </a:r>
+            <a:r>
+              <a:rPr sz="1500" b="1">
+                <a:solidFill>
+                  <a:srgbClr val="1F2937"/>
+                </a:solidFill>
+                <a:latin typeface="Segoe UI"/>
+              </a:rPr>
+              <a:t>Two front doors</a:t>
+            </a:r>
+            <a:r>
+              <a:rPr sz="1400" b="0">
+                <a:solidFill>
+                  <a:srgbClr val="6B7280"/>
+                </a:solidFill>
+                <a:latin typeface="Segoe UI"/>
+              </a:rPr>
+              <a:t>  —  paste a meeting transcript, or upload a BRD, PRD, or spec (.txt, .md, .docx, .pdf)</a:t>
+            </a:r>
+          </a:p>
+          <a:p>
+            <a:pPr>
+              <a:spcBef>
+                <a:spcPts val="0"/>
+              </a:spcBef>
+              <a:spcAft>
+                <a:spcPts val="1500"/>
+              </a:spcAft>
+            </a:pPr>
+            <a:r>
+              <a:rPr sz="1500" b="1">
+                <a:solidFill>
+                  <a:srgbClr val="4F46E5"/>
+                </a:solidFill>
+                <a:latin typeface="Segoe UI"/>
+              </a:rPr>
+              <a:t>●  </a:t>
+            </a:r>
+            <a:r>
+              <a:rPr sz="1500" b="1">
+                <a:solidFill>
+                  <a:srgbClr val="1F2937"/>
+                </a:solidFill>
+                <a:latin typeface="Segoe UI"/>
+              </a:rPr>
+              <a:t>Auto-detected</a:t>
+            </a:r>
+            <a:r>
+              <a:rPr sz="1400" b="0">
+                <a:solidFill>
+                  <a:srgbClr val="6B7280"/>
+                </a:solidFill>
+                <a:latin typeface="Segoe UI"/>
+              </a:rPr>
+              <a:t>  —  the agent recognizes transcript vs. structured document, or you set the mode with a one-click toggle</a:t>
+            </a:r>
+          </a:p>
+          <a:p>
+            <a:pPr>
+              <a:spcBef>
+                <a:spcPts val="0"/>
+              </a:spcBef>
+              <a:spcAft>
+                <a:spcPts val="1500"/>
+              </a:spcAft>
+            </a:pPr>
+            <a:r>
+              <a:rPr sz="1500" b="1">
+                <a:solidFill>
+                  <a:srgbClr val="4F46E5"/>
+                </a:solidFill>
+                <a:latin typeface="Segoe UI"/>
+              </a:rPr>
+              <a:t>●  </a:t>
+            </a:r>
+            <a:r>
+              <a:rPr sz="1500" b="1">
+                <a:solidFill>
+                  <a:srgbClr val="1F2937"/>
+                </a:solidFill>
+                <a:latin typeface="Segoe UI"/>
+              </a:rPr>
+              <a:t>Handled on its own terms</a:t>
+            </a:r>
+            <a:r>
+              <a:rPr sz="1400" b="0">
+                <a:solidFill>
+                  <a:srgbClr val="6B7280"/>
+                </a:solidFill>
+                <a:latin typeface="Segoe UI"/>
+              </a:rPr>
+              <a:t>  —  transcripts get speech cleanup and inferred story boundaries; BRDs keep their own headings and itemization</a:t>
+            </a:r>
+          </a:p>
+          <a:p>
+            <a:pPr>
+              <a:spcBef>
+                <a:spcPts val="0"/>
+              </a:spcBef>
+              <a:spcAft>
+                <a:spcPts val="1500"/>
+              </a:spcAft>
+            </a:pPr>
+            <a:r>
+              <a:rPr sz="1500" b="1">
+                <a:solidFill>
+                  <a:srgbClr val="4F46E5"/>
+                </a:solidFill>
+                <a:latin typeface="Segoe UI"/>
+              </a:rPr>
+              <a:t>●  </a:t>
+            </a:r>
+            <a:r>
+              <a:rPr sz="1500" b="1">
+                <a:solidFill>
+                  <a:srgbClr val="1F2937"/>
+                </a:solidFill>
+                <a:latin typeface="Segoe UI"/>
+              </a:rPr>
+              <a:t>Grounded in your docs</a:t>
+            </a:r>
+            <a:r>
+              <a:rPr sz="1400" b="0">
+                <a:solidFill>
+                  <a:srgbClr val="6B7280"/>
+                </a:solidFill>
+                <a:latin typeface="Segoe UI"/>
+              </a:rPr>
+              <a:t>  —  an optional Confluence page and its attached PDFs are pulled in as context and linked back on every filed issue</a:t>
+            </a:r>
+          </a:p>
+          <a:p>
+            <a:pPr>
+              <a:spcBef>
+                <a:spcPts val="0"/>
+              </a:spcBef>
+              <a:spcAft>
+                <a:spcPts val="1500"/>
+              </a:spcAft>
+            </a:pPr>
+            <a:r>
+              <a:rPr sz="1500" b="1">
+                <a:solidFill>
+                  <a:srgbClr val="4F46E5"/>
+                </a:solidFill>
+                <a:latin typeface="Segoe UI"/>
+              </a:rPr>
+              <a:t>●  </a:t>
+            </a:r>
+            <a:r>
+              <a:rPr sz="1500" b="1">
+                <a:solidFill>
+                  <a:srgbClr val="1F2937"/>
+                </a:solidFill>
+                <a:latin typeface="Segoe UI"/>
+              </a:rPr>
+              <a:t>Same guardrails, either way</a:t>
+            </a:r>
+            <a:r>
+              <a:rPr sz="1400" b="0">
+                <a:solidFill>
+                  <a:srgbClr val="6B7280"/>
+                </a:solidFill>
+                <a:latin typeface="Segoe UI"/>
+              </a:rPr>
+              <a:t>  —  local PII masking, targeted questions, INVEST scoring, and the quality gate apply to every source</a:t>
+            </a:r>
+          </a:p>
+        </p:txBody>
+      </p:sp>
+      <p:sp>
+        <p:nvSpPr>
+          <p:cNvPr id="8" name="TextBox 7"/>
+          <p:cNvSpPr txBox="1"/>
+          <p:nvPr/>
+        </p:nvSpPr>
+        <p:spPr>
+          <a:xfrm>
+            <a:off x="685800" y="6455664"/>
+            <a:ext cx="7315200" cy="274320"/>
+          </a:xfrm>
+          <a:prstGeom prst="rect">
+            <a:avLst/>
+          </a:prstGeom>
+          <a:noFill/>
+        </p:spPr>
+        <p:txBody>
+          <a:bodyPr wrap="square" anchor="t" lIns="0" rIns="0" tIns="0" bIns="0">
+            <a:spAutoFit/>
+          </a:bodyPr>
+          <a:lstStyle/>
+          <a:p>
+            <a:pPr algn="l">
+              <a:spcBef>
+                <a:spcPts val="0"/>
+              </a:spcBef>
+              <a:spcAft>
+                <a:spcPts val="0"/>
+              </a:spcAft>
+            </a:pPr>
+            <a:r>
+              <a:rPr sz="900" b="0">
+                <a:solidFill>
+                  <a:srgbClr val="6B7280"/>
+                </a:solidFill>
+                <a:latin typeface="Segoe UI"/>
+              </a:rPr>
+              <a:t>AI JIRA Story Generator  ·  Business Case</a:t>
+            </a:r>
+          </a:p>
+        </p:txBody>
+      </p:sp>
+      <p:sp>
+        <p:nvSpPr>
+          <p:cNvPr id="9" name="TextBox 8"/>
+          <p:cNvSpPr txBox="1"/>
+          <p:nvPr/>
+        </p:nvSpPr>
+        <p:spPr>
+          <a:xfrm>
+            <a:off x="10515600" y="6455664"/>
+            <a:ext cx="1005840" cy="274320"/>
+          </a:xfrm>
+          <a:prstGeom prst="rect">
+            <a:avLst/>
+          </a:prstGeom>
+          <a:noFill/>
+        </p:spPr>
+        <p:txBody>
+          <a:bodyPr wrap="square" anchor="t" lIns="0" rIns="0" tIns="0" bIns="0">
+            <a:spAutoFit/>
+          </a:bodyPr>
+          <a:lstStyle/>
+          <a:p>
+            <a:pPr algn="r">
+              <a:spcBef>
+                <a:spcPts val="0"/>
+              </a:spcBef>
+              <a:spcAft>
+                <a:spcPts val="0"/>
+              </a:spcAft>
+            </a:pPr>
+            <a:r>
+              <a:rPr sz="900" b="0">
+                <a:solidFill>
+                  <a:srgbClr val="6B7280"/>
+                </a:solidFill>
+                <a:latin typeface="Segoe UI"/>
+              </a:rPr>
+              <a:t>3</a:t>
             </a:r>
           </a:p>
         </p:txBody>
@@ -8030,7 +8557,7 @@
                 </a:solidFill>
                 <a:latin typeface="Segoe UI"/>
               </a:rPr>
-              <a:t>Paste notes, a transcript, or a feature description. The agent cleans and de-identifies the text, understands the request in context of your applications, drafts well-formed JIRA items, asks you when it is unsure, scores every item for quality, refines the weak ones, and files them straight into JIRA.</a:t>
+              <a:t>Paste a meeting transcript or upload a BRD, spec, or feature description. The agent auto-detects the source type, cleans and de-identifies the text, understands the request in context of your applications, drafts well-formed JIRA items, asks you when it is unsure, scores every item for quality, refines the weak ones, and files them straight into JIRA.</a:t>
             </a:r>
           </a:p>
         </p:txBody>
@@ -9089,7 +9616,7 @@
                 </a:solidFill>
                 <a:latin typeface="Segoe UI"/>
               </a:rPr>
-              <a:t>1. Ingest notes</a:t>
+              <a:t>1. Ingest transcript / BRD</a:t>
             </a:r>
           </a:p>
         </p:txBody>
@@ -9694,7 +10221,7 @@
                 </a:solidFill>
                 <a:latin typeface="Segoe UI"/>
               </a:rPr>
-              <a:t>PII is masked locally before any model call. Drafting runs concurrently for speed; each draft can pause to ask you a clear, item-specific question rather than guess.</a:t>
+              <a:t>PII is masked locally before any model call. Transcripts get speech cleanup while BRDs and specs keep their own structure — auto-detected, or set with a one-click toggle. Drafting runs concurrently; each draft can pause to ask a clear, item-specific question rather than guess.</a:t>
             </a:r>
           </a:p>
         </p:txBody>
@@ -9778,7 +10305,7 @@
                 </a:solidFill>
                 <a:latin typeface="Segoe UI"/>
               </a:rPr>
-              <a:t>3</a:t>
+              <a:t>4</a:t>
             </a:r>
           </a:p>
         </p:txBody>
@@ -10736,7 +11263,7 @@
                 </a:solidFill>
                 <a:latin typeface="Segoe UI"/>
               </a:rPr>
-              <a:t>4</a:t>
+              <a:t>5</a:t>
             </a:r>
           </a:p>
         </p:txBody>
@@ -11176,7 +11703,7 @@
                 </a:solidFill>
                 <a:latin typeface="Segoe UI"/>
               </a:rPr>
-              <a:t>5</a:t>
+              <a:t>6</a:t>
             </a:r>
           </a:p>
         </p:txBody>
@@ -12070,7 +12597,7 @@
                 </a:solidFill>
                 <a:latin typeface="Segoe UI"/>
               </a:rPr>
-              <a:t>6</a:t>
+              <a:t>7</a:t>
             </a:r>
           </a:p>
         </p:txBody>
@@ -12486,7 +13013,7 @@
                 </a:solidFill>
                 <a:latin typeface="Segoe UI"/>
               </a:rPr>
-              <a:t>7</a:t>
+              <a:t>8</a:t>
             </a:r>
           </a:p>
         </p:txBody>
@@ -13836,7 +14363,7 @@
                 </a:solidFill>
                 <a:latin typeface="Segoe UI"/>
               </a:rPr>
-              <a:t>8</a:t>
+              <a:t>9</a:t>
             </a:r>
           </a:p>
         </p:txBody>

</xml_diff>